<commit_message>
Fix test count (204), remove stale Plotly/networkx mentions, update repo links in report, deck and notebook
</commit_message>
<xml_diff>
--- a/final_review/DAA_Campus_Shuttle_Deck.pptx
+++ b/final_review/DAA_Campus_Shuttle_Deck.pptx
@@ -3101,7 +3101,7 @@
       <p:grpSpPr/>
       <p:pic>
         <p:nvPicPr>
-          <p:cNvPr id="2" name="Picture 1" descr="s-01.png"/>
+          <p:cNvPr id="2" name="Picture 1" descr="j01.jpg"/>
           <p:cNvPicPr>
             <a:picLocks noChangeAspect="1"/>
           </p:cNvPicPr>
@@ -3143,7 +3143,7 @@
       <p:grpSpPr/>
       <p:pic>
         <p:nvPicPr>
-          <p:cNvPr id="2" name="Picture 1" descr="s-10.png"/>
+          <p:cNvPr id="2" name="Picture 1" descr="j10.jpg"/>
           <p:cNvPicPr>
             <a:picLocks noChangeAspect="1"/>
           </p:cNvPicPr>
@@ -3185,7 +3185,7 @@
       <p:grpSpPr/>
       <p:pic>
         <p:nvPicPr>
-          <p:cNvPr id="2" name="Picture 1" descr="s-11.png"/>
+          <p:cNvPr id="2" name="Picture 1" descr="j11.jpg"/>
           <p:cNvPicPr>
             <a:picLocks noChangeAspect="1"/>
           </p:cNvPicPr>
@@ -3227,7 +3227,7 @@
       <p:grpSpPr/>
       <p:pic>
         <p:nvPicPr>
-          <p:cNvPr id="2" name="Picture 1" descr="s-12.png"/>
+          <p:cNvPr id="2" name="Picture 1" descr="j12.jpg"/>
           <p:cNvPicPr>
             <a:picLocks noChangeAspect="1"/>
           </p:cNvPicPr>
@@ -3269,7 +3269,7 @@
       <p:grpSpPr/>
       <p:pic>
         <p:nvPicPr>
-          <p:cNvPr id="2" name="Picture 1" descr="s-02.png"/>
+          <p:cNvPr id="2" name="Picture 1" descr="j02.jpg"/>
           <p:cNvPicPr>
             <a:picLocks noChangeAspect="1"/>
           </p:cNvPicPr>
@@ -3311,7 +3311,7 @@
       <p:grpSpPr/>
       <p:pic>
         <p:nvPicPr>
-          <p:cNvPr id="2" name="Picture 1" descr="s-03.png"/>
+          <p:cNvPr id="2" name="Picture 1" descr="j03.jpg"/>
           <p:cNvPicPr>
             <a:picLocks noChangeAspect="1"/>
           </p:cNvPicPr>
@@ -3353,7 +3353,7 @@
       <p:grpSpPr/>
       <p:pic>
         <p:nvPicPr>
-          <p:cNvPr id="2" name="Picture 1" descr="s-04.png"/>
+          <p:cNvPr id="2" name="Picture 1" descr="j04.jpg"/>
           <p:cNvPicPr>
             <a:picLocks noChangeAspect="1"/>
           </p:cNvPicPr>
@@ -3395,7 +3395,7 @@
       <p:grpSpPr/>
       <p:pic>
         <p:nvPicPr>
-          <p:cNvPr id="2" name="Picture 1" descr="s-05.png"/>
+          <p:cNvPr id="2" name="Picture 1" descr="j05.jpg"/>
           <p:cNvPicPr>
             <a:picLocks noChangeAspect="1"/>
           </p:cNvPicPr>
@@ -3437,7 +3437,7 @@
       <p:grpSpPr/>
       <p:pic>
         <p:nvPicPr>
-          <p:cNvPr id="2" name="Picture 1" descr="s-06.png"/>
+          <p:cNvPr id="2" name="Picture 1" descr="j06.jpg"/>
           <p:cNvPicPr>
             <a:picLocks noChangeAspect="1"/>
           </p:cNvPicPr>
@@ -3479,7 +3479,7 @@
       <p:grpSpPr/>
       <p:pic>
         <p:nvPicPr>
-          <p:cNvPr id="2" name="Picture 1" descr="s-07.png"/>
+          <p:cNvPr id="2" name="Picture 1" descr="j07.jpg"/>
           <p:cNvPicPr>
             <a:picLocks noChangeAspect="1"/>
           </p:cNvPicPr>
@@ -3521,7 +3521,7 @@
       <p:grpSpPr/>
       <p:pic>
         <p:nvPicPr>
-          <p:cNvPr id="2" name="Picture 1" descr="s-08.png"/>
+          <p:cNvPr id="2" name="Picture 1" descr="j08.jpg"/>
           <p:cNvPicPr>
             <a:picLocks noChangeAspect="1"/>
           </p:cNvPicPr>
@@ -3563,7 +3563,7 @@
       <p:grpSpPr/>
       <p:pic>
         <p:nvPicPr>
-          <p:cNvPr id="2" name="Picture 1" descr="s-09.png"/>
+          <p:cNvPr id="2" name="Picture 1" descr="j09.jpg"/>
           <p:cNvPicPr>
             <a:picLocks noChangeAspect="1"/>
           </p:cNvPicPr>

</xml_diff>